<commit_message>
docs(midterm)+ui: dual-narrative highlights and visible citations
</commit_message>
<xml_diff>
--- a/中期答辩材料/汇报PPT/中期汇报-v5.pptx
+++ b/中期答辩材料/汇报PPT/中期汇报-v5.pptx
@@ -3971,7 +3971,7 @@
                 </a:solidFill>
                 <a:latin typeface="Microsoft YaHei"/>
               </a:rPr>
-              <a:t>中期结论与下一步</a:t>
+              <a:t>后期计划与中期结论</a:t>
             </a:r>
           </a:p>
         </p:txBody>
@@ -4010,7 +4010,7 @@
                 </a:solidFill>
                 <a:latin typeface="Microsoft YaHei"/>
               </a:rPr>
-              <a:t>可演示、可追溯、可核对；不宣称通用多模态或人工事实准确率</a:t>
+              <a:t>四条可汇报的下一步；不承诺公网生产部署</a:t>
             </a:r>
           </a:p>
         </p:txBody>
@@ -4140,63 +4140,24 @@
       </p:sp>
       <p:sp>
         <p:nvSpPr>
-          <p:cNvPr id="7" name="TextBox 6"/>
-          <p:cNvSpPr txBox="1"/>
-          <p:nvPr/>
-        </p:nvSpPr>
-        <p:spPr>
-          <a:xfrm>
-            <a:off x="749808" y="1600200"/>
-            <a:ext cx="1828800" cy="365760"/>
-          </a:xfrm>
-          <a:prstGeom prst="rect">
-            <a:avLst/>
-          </a:prstGeom>
-          <a:noFill/>
-        </p:spPr>
-        <p:txBody>
-          <a:bodyPr wrap="square" lIns="36576" rIns="36576" tIns="18288" bIns="18288" anchor="ctr">
-            <a:spAutoFit/>
-          </a:bodyPr>
-          <a:lstStyle/>
-          <a:p>
-            <a:pPr algn="l">
-              <a:spcAft>
-                <a:spcPts val="200"/>
-              </a:spcAft>
-            </a:pPr>
-            <a:r>
-              <a:rPr sz="2100" b="1">
-                <a:solidFill>
-                  <a:srgbClr val="26734E"/>
-                </a:solidFill>
-                <a:latin typeface="Microsoft YaHei"/>
-              </a:rPr>
-              <a:t>已完成</a:t>
-            </a:r>
-          </a:p>
-        </p:txBody>
-      </p:sp>
-      <p:sp>
-        <p:nvSpPr>
-          <p:cNvPr id="8" name="Rounded Rectangle 7"/>
+          <p:cNvPr id="7" name="Rounded Rectangle 6"/>
           <p:cNvSpPr/>
           <p:nvPr/>
         </p:nvSpPr>
         <p:spPr>
           <a:xfrm>
-            <a:off x="749808" y="2057400"/>
-            <a:ext cx="5074920" cy="530352"/>
+            <a:off x="502920" y="1600200"/>
+            <a:ext cx="5532120" cy="1371600"/>
           </a:xfrm>
           <a:prstGeom prst="roundRect">
             <a:avLst/>
           </a:prstGeom>
           <a:solidFill>
-            <a:srgbClr val="E4F1E9"/>
+            <a:srgbClr val="E4F2F0"/>
           </a:solidFill>
           <a:ln w="13970">
             <a:solidFill>
-              <a:srgbClr val="E4F1E9"/>
+              <a:srgbClr val="247D78"/>
             </a:solidFill>
           </a:ln>
         </p:spPr>
@@ -4215,111 +4176,62 @@
           </a:fontRef>
         </p:style>
         <p:txBody>
-          <a:bodyPr rtlCol="0" anchor="ctr"/>
-          <a:lstStyle/>
-          <a:p>
-            <a:pPr algn="ctr"/>
-          </a:p>
-        </p:txBody>
-      </p:sp>
-      <p:sp>
-        <p:nvSpPr>
-          <p:cNvPr id="9" name="TextBox 8"/>
-          <p:cNvSpPr txBox="1"/>
-          <p:nvPr/>
-        </p:nvSpPr>
-        <p:spPr>
-          <a:xfrm>
-            <a:off x="859536" y="2130552"/>
-            <a:ext cx="411480" cy="365760"/>
-          </a:xfrm>
-          <a:prstGeom prst="rect">
-            <a:avLst/>
-          </a:prstGeom>
-          <a:noFill/>
-        </p:spPr>
-        <p:txBody>
-          <a:bodyPr wrap="square" lIns="36576" rIns="36576" tIns="18288" bIns="18288" anchor="ctr">
-            <a:spAutoFit/>
-          </a:bodyPr>
-          <a:lstStyle/>
-          <a:p>
-            <a:pPr algn="ctr">
-              <a:spcAft>
-                <a:spcPts val="200"/>
-              </a:spcAft>
-            </a:pPr>
-            <a:r>
-              <a:rPr sz="1400" b="1">
-                <a:solidFill>
-                  <a:srgbClr val="26734E"/>
-                </a:solidFill>
-                <a:latin typeface="Microsoft YaHei"/>
-              </a:rPr>
-              <a:t>01</a:t>
-            </a:r>
-          </a:p>
-        </p:txBody>
-      </p:sp>
-      <p:sp>
-        <p:nvSpPr>
-          <p:cNvPr id="10" name="TextBox 9"/>
-          <p:cNvSpPr txBox="1"/>
-          <p:nvPr/>
-        </p:nvSpPr>
-        <p:spPr>
-          <a:xfrm>
-            <a:off x="1353312" y="2130552"/>
-            <a:ext cx="4315968" cy="384048"/>
-          </a:xfrm>
-          <a:prstGeom prst="rect">
-            <a:avLst/>
-          </a:prstGeom>
-          <a:noFill/>
-        </p:spPr>
-        <p:txBody>
-          <a:bodyPr wrap="square" lIns="36576" rIns="36576" tIns="18288" bIns="18288" anchor="ctr">
-            <a:spAutoFit/>
-          </a:bodyPr>
-          <a:lstStyle/>
-          <a:p>
-            <a:pPr algn="l">
-              <a:spcAft>
-                <a:spcPts val="200"/>
-              </a:spcAft>
-            </a:pPr>
-            <a:r>
-              <a:rPr sz="1400" b="1">
+          <a:bodyPr rtlCol="0" anchor="t" wrap="square" lIns="146304" rIns="146304" tIns="91440" bIns="73152"/>
+          <a:lstStyle/>
+          <a:p>
+            <a:pPr algn="l">
+              <a:spcAft>
+                <a:spcPts val="600"/>
+              </a:spcAft>
+            </a:pPr>
+            <a:r>
+              <a:rPr sz="1700" b="1">
+                <a:solidFill>
+                  <a:srgbClr val="247D78"/>
+                </a:solidFill>
+                <a:latin typeface="Microsoft YaHei"/>
+              </a:rPr>
+              <a:t>01 人工复核</a:t>
+            </a:r>
+          </a:p>
+          <a:p>
+            <a:pPr algn="l">
+              <a:spcAft>
+                <a:spcPts val="200"/>
+              </a:spcAft>
+            </a:pPr>
+            <a:r>
+              <a:rPr sz="1400">
                 <a:solidFill>
                   <a:srgbClr val="263642"/>
                 </a:solidFill>
                 <a:latin typeface="Microsoft YaHei"/>
               </a:rPr>
-              <a:t>中文四课演示库 4 / 27 / 2,501（cn_v2）</a:t>
-            </a:r>
-          </a:p>
-        </p:txBody>
-      </p:sp>
-      <p:sp>
-        <p:nvSpPr>
-          <p:cNvPr id="11" name="Rounded Rectangle 10"/>
+              <a:t>小样本抽检事实正确与引用支持是否一致</a:t>
+            </a:r>
+          </a:p>
+        </p:txBody>
+      </p:sp>
+      <p:sp>
+        <p:nvSpPr>
+          <p:cNvPr id="8" name="Rounded Rectangle 7"/>
           <p:cNvSpPr/>
           <p:nvPr/>
         </p:nvSpPr>
         <p:spPr>
           <a:xfrm>
-            <a:off x="749808" y="2715768"/>
-            <a:ext cx="5074920" cy="530352"/>
+            <a:off x="6309359" y="1600200"/>
+            <a:ext cx="5532120" cy="1371600"/>
           </a:xfrm>
           <a:prstGeom prst="roundRect">
             <a:avLst/>
           </a:prstGeom>
           <a:solidFill>
-            <a:srgbClr val="E4F1E9"/>
+            <a:srgbClr val="FBF0D8"/>
           </a:solidFill>
           <a:ln w="13970">
             <a:solidFill>
-              <a:srgbClr val="E4F1E9"/>
+              <a:srgbClr val="D39A37"/>
             </a:solidFill>
           </a:ln>
         </p:spPr>
@@ -4338,111 +4250,62 @@
           </a:fontRef>
         </p:style>
         <p:txBody>
-          <a:bodyPr rtlCol="0" anchor="ctr"/>
-          <a:lstStyle/>
-          <a:p>
-            <a:pPr algn="ctr"/>
-          </a:p>
-        </p:txBody>
-      </p:sp>
-      <p:sp>
-        <p:nvSpPr>
-          <p:cNvPr id="12" name="TextBox 11"/>
-          <p:cNvSpPr txBox="1"/>
-          <p:nvPr/>
-        </p:nvSpPr>
-        <p:spPr>
-          <a:xfrm>
-            <a:off x="859536" y="2788920"/>
-            <a:ext cx="411480" cy="365760"/>
-          </a:xfrm>
-          <a:prstGeom prst="rect">
-            <a:avLst/>
-          </a:prstGeom>
-          <a:noFill/>
-        </p:spPr>
-        <p:txBody>
-          <a:bodyPr wrap="square" lIns="36576" rIns="36576" tIns="18288" bIns="18288" anchor="ctr">
-            <a:spAutoFit/>
-          </a:bodyPr>
-          <a:lstStyle/>
-          <a:p>
-            <a:pPr algn="ctr">
-              <a:spcAft>
-                <a:spcPts val="200"/>
-              </a:spcAft>
-            </a:pPr>
-            <a:r>
-              <a:rPr sz="1400" b="1">
-                <a:solidFill>
-                  <a:srgbClr val="26734E"/>
-                </a:solidFill>
-                <a:latin typeface="Microsoft YaHei"/>
-              </a:rPr>
-              <a:t>02</a:t>
-            </a:r>
-          </a:p>
-        </p:txBody>
-      </p:sp>
-      <p:sp>
-        <p:nvSpPr>
-          <p:cNvPr id="13" name="TextBox 12"/>
-          <p:cNvSpPr txBox="1"/>
-          <p:nvPr/>
-        </p:nvSpPr>
-        <p:spPr>
-          <a:xfrm>
-            <a:off x="1353312" y="2788920"/>
-            <a:ext cx="4315968" cy="384048"/>
-          </a:xfrm>
-          <a:prstGeom prst="rect">
-            <a:avLst/>
-          </a:prstGeom>
-          <a:noFill/>
-        </p:spPr>
-        <p:txBody>
-          <a:bodyPr wrap="square" lIns="36576" rIns="36576" tIns="18288" bIns="18288" anchor="ctr">
-            <a:spAutoFit/>
-          </a:bodyPr>
-          <a:lstStyle/>
-          <a:p>
-            <a:pPr algn="l">
-              <a:spcAft>
-                <a:spcPts val="200"/>
-              </a:spcAft>
-            </a:pPr>
-            <a:r>
-              <a:rPr sz="1400" b="1">
+          <a:bodyPr rtlCol="0" anchor="t" wrap="square" lIns="146304" rIns="146304" tIns="91440" bIns="73152"/>
+          <a:lstStyle/>
+          <a:p>
+            <a:pPr algn="l">
+              <a:spcAft>
+                <a:spcPts val="600"/>
+              </a:spcAft>
+            </a:pPr>
+            <a:r>
+              <a:rPr sz="1700" b="1">
+                <a:solidFill>
+                  <a:srgbClr val="D39A37"/>
+                </a:solidFill>
+                <a:latin typeface="Microsoft YaHei"/>
+              </a:rPr>
+              <a:t>02 检索对照</a:t>
+            </a:r>
+          </a:p>
+          <a:p>
+            <a:pPr algn="l">
+              <a:spcAft>
+                <a:spcPts val="200"/>
+              </a:spcAft>
+            </a:pPr>
+            <a:r>
+              <a:rPr sz="1400">
                 <a:solidFill>
                   <a:srgbClr val="263642"/>
                 </a:solidFill>
                 <a:latin typeface="Microsoft YaHei"/>
               </a:rPr>
-              <a:t>业务闭环可走：提问 → 引用 → 回原页</a:t>
-            </a:r>
-          </a:p>
-        </p:txBody>
-      </p:sp>
-      <p:sp>
-        <p:nvSpPr>
-          <p:cNvPr id="14" name="Rounded Rectangle 13"/>
+              <a:t>Hybrid / rerank 与 dense 对照，有无收益都如实报</a:t>
+            </a:r>
+          </a:p>
+        </p:txBody>
+      </p:sp>
+      <p:sp>
+        <p:nvSpPr>
+          <p:cNvPr id="9" name="Rounded Rectangle 8"/>
           <p:cNvSpPr/>
           <p:nvPr/>
         </p:nvSpPr>
         <p:spPr>
           <a:xfrm>
-            <a:off x="749808" y="3374136"/>
-            <a:ext cx="5074920" cy="530352"/>
+            <a:off x="502920" y="3154680"/>
+            <a:ext cx="5532120" cy="1371600"/>
           </a:xfrm>
           <a:prstGeom prst="roundRect">
             <a:avLst/>
           </a:prstGeom>
           <a:solidFill>
-            <a:srgbClr val="E4F1E9"/>
+            <a:srgbClr val="E4F2F0"/>
           </a:solidFill>
           <a:ln w="13970">
             <a:solidFill>
-              <a:srgbClr val="E4F1E9"/>
+              <a:srgbClr val="247D78"/>
             </a:solidFill>
           </a:ln>
         </p:spPr>
@@ -4461,111 +4324,62 @@
           </a:fontRef>
         </p:style>
         <p:txBody>
-          <a:bodyPr rtlCol="0" anchor="ctr"/>
-          <a:lstStyle/>
-          <a:p>
-            <a:pPr algn="ctr"/>
-          </a:p>
-        </p:txBody>
-      </p:sp>
-      <p:sp>
-        <p:nvSpPr>
-          <p:cNvPr id="15" name="TextBox 14"/>
-          <p:cNvSpPr txBox="1"/>
-          <p:nvPr/>
-        </p:nvSpPr>
-        <p:spPr>
-          <a:xfrm>
-            <a:off x="859536" y="3447288"/>
-            <a:ext cx="411480" cy="365760"/>
-          </a:xfrm>
-          <a:prstGeom prst="rect">
-            <a:avLst/>
-          </a:prstGeom>
-          <a:noFill/>
-        </p:spPr>
-        <p:txBody>
-          <a:bodyPr wrap="square" lIns="36576" rIns="36576" tIns="18288" bIns="18288" anchor="ctr">
-            <a:spAutoFit/>
-          </a:bodyPr>
-          <a:lstStyle/>
-          <a:p>
-            <a:pPr algn="ctr">
-              <a:spcAft>
-                <a:spcPts val="200"/>
-              </a:spcAft>
-            </a:pPr>
-            <a:r>
-              <a:rPr sz="1400" b="1">
-                <a:solidFill>
-                  <a:srgbClr val="26734E"/>
-                </a:solidFill>
-                <a:latin typeface="Microsoft YaHei"/>
-              </a:rPr>
-              <a:t>03</a:t>
-            </a:r>
-          </a:p>
-        </p:txBody>
-      </p:sp>
-      <p:sp>
-        <p:nvSpPr>
-          <p:cNvPr id="16" name="TextBox 15"/>
-          <p:cNvSpPr txBox="1"/>
-          <p:nvPr/>
-        </p:nvSpPr>
-        <p:spPr>
-          <a:xfrm>
-            <a:off x="1353312" y="3447288"/>
-            <a:ext cx="4315968" cy="384048"/>
-          </a:xfrm>
-          <a:prstGeom prst="rect">
-            <a:avLst/>
-          </a:prstGeom>
-          <a:noFill/>
-        </p:spPr>
-        <p:txBody>
-          <a:bodyPr wrap="square" lIns="36576" rIns="36576" tIns="18288" bIns="18288" anchor="ctr">
-            <a:spAutoFit/>
-          </a:bodyPr>
-          <a:lstStyle/>
-          <a:p>
-            <a:pPr algn="l">
-              <a:spcAft>
-                <a:spcPts val="200"/>
-              </a:spcAft>
-            </a:pPr>
-            <a:r>
-              <a:rPr sz="1400" b="1">
+          <a:bodyPr rtlCol="0" anchor="t" wrap="square" lIns="146304" rIns="146304" tIns="91440" bIns="73152"/>
+          <a:lstStyle/>
+          <a:p>
+            <a:pPr algn="l">
+              <a:spcAft>
+                <a:spcPts val="600"/>
+              </a:spcAft>
+            </a:pPr>
+            <a:r>
+              <a:rPr sz="1700" b="1">
+                <a:solidFill>
+                  <a:srgbClr val="247D78"/>
+                </a:solidFill>
+                <a:latin typeface="Microsoft YaHei"/>
+              </a:rPr>
+              <a:t>03 同义问题组</a:t>
+            </a:r>
+          </a:p>
+          <a:p>
+            <a:pPr algn="l">
+              <a:spcAft>
+                <a:spcPts val="200"/>
+              </a:spcAft>
+            </a:pPr>
+            <a:r>
+              <a:rPr sz="1400">
                 <a:solidFill>
                   <a:srgbClr val="263642"/>
                 </a:solidFill>
                 <a:latin typeface="Microsoft YaHei"/>
               </a:rPr>
-              <a:t>拒答与有据回答可区分演示</a:t>
-            </a:r>
-          </a:p>
-        </p:txBody>
-      </p:sp>
-      <p:sp>
-        <p:nvSpPr>
-          <p:cNvPr id="17" name="Rounded Rectangle 16"/>
+              <a:t>教师侧校准后再开，服务备课线索</a:t>
+            </a:r>
+          </a:p>
+        </p:txBody>
+      </p:sp>
+      <p:sp>
+        <p:nvSpPr>
+          <p:cNvPr id="10" name="Rounded Rectangle 9"/>
           <p:cNvSpPr/>
           <p:nvPr/>
         </p:nvSpPr>
         <p:spPr>
           <a:xfrm>
-            <a:off x="749808" y="4032504"/>
-            <a:ext cx="5074920" cy="530352"/>
+            <a:off x="6309359" y="3154680"/>
+            <a:ext cx="5532120" cy="1371600"/>
           </a:xfrm>
           <a:prstGeom prst="roundRect">
             <a:avLst/>
           </a:prstGeom>
           <a:solidFill>
-            <a:srgbClr val="E4F1E9"/>
+            <a:srgbClr val="FBF0D8"/>
           </a:solidFill>
           <a:ln w="13970">
             <a:solidFill>
-              <a:srgbClr val="E4F1E9"/>
+              <a:srgbClr val="D39A37"/>
             </a:solidFill>
           </a:ln>
         </p:spPr>
@@ -4584,632 +4398,52 @@
           </a:fontRef>
         </p:style>
         <p:txBody>
-          <a:bodyPr rtlCol="0" anchor="ctr"/>
-          <a:lstStyle/>
-          <a:p>
-            <a:pPr algn="ctr"/>
-          </a:p>
-        </p:txBody>
-      </p:sp>
-      <p:sp>
-        <p:nvSpPr>
-          <p:cNvPr id="18" name="TextBox 17"/>
-          <p:cNvSpPr txBox="1"/>
-          <p:nvPr/>
-        </p:nvSpPr>
-        <p:spPr>
-          <a:xfrm>
-            <a:off x="859536" y="4105656"/>
-            <a:ext cx="411480" cy="365760"/>
-          </a:xfrm>
-          <a:prstGeom prst="rect">
-            <a:avLst/>
-          </a:prstGeom>
-          <a:noFill/>
-        </p:spPr>
-        <p:txBody>
-          <a:bodyPr wrap="square" lIns="36576" rIns="36576" tIns="18288" bIns="18288" anchor="ctr">
-            <a:spAutoFit/>
-          </a:bodyPr>
-          <a:lstStyle/>
-          <a:p>
-            <a:pPr algn="ctr">
-              <a:spcAft>
-                <a:spcPts val="200"/>
-              </a:spcAft>
-            </a:pPr>
-            <a:r>
-              <a:rPr sz="1400" b="1">
-                <a:solidFill>
-                  <a:srgbClr val="26734E"/>
-                </a:solidFill>
-                <a:latin typeface="Microsoft YaHei"/>
-              </a:rPr>
-              <a:t>04</a:t>
-            </a:r>
-          </a:p>
-        </p:txBody>
-      </p:sp>
-      <p:sp>
-        <p:nvSpPr>
-          <p:cNvPr id="19" name="TextBox 18"/>
-          <p:cNvSpPr txBox="1"/>
-          <p:nvPr/>
-        </p:nvSpPr>
-        <p:spPr>
-          <a:xfrm>
-            <a:off x="1353312" y="4105656"/>
-            <a:ext cx="4315968" cy="384048"/>
-          </a:xfrm>
-          <a:prstGeom prst="rect">
-            <a:avLst/>
-          </a:prstGeom>
-          <a:noFill/>
-        </p:spPr>
-        <p:txBody>
-          <a:bodyPr wrap="square" lIns="36576" rIns="36576" tIns="18288" bIns="18288" anchor="ctr">
-            <a:spAutoFit/>
-          </a:bodyPr>
-          <a:lstStyle/>
-          <a:p>
-            <a:pPr algn="l">
-              <a:spcAft>
-                <a:spcPts val="200"/>
-              </a:spcAft>
-            </a:pPr>
-            <a:r>
-              <a:rPr sz="1400" b="1">
+          <a:bodyPr rtlCol="0" anchor="t" wrap="square" lIns="146304" rIns="146304" tIns="91440" bIns="73152"/>
+          <a:lstStyle/>
+          <a:p>
+            <a:pPr algn="l">
+              <a:spcAft>
+                <a:spcPts val="600"/>
+              </a:spcAft>
+            </a:pPr>
+            <a:r>
+              <a:rPr sz="1700" b="1">
+                <a:solidFill>
+                  <a:srgbClr val="D39A37"/>
+                </a:solidFill>
+                <a:latin typeface="Microsoft YaHei"/>
+              </a:rPr>
+              <a:t>04 试用与成本</a:t>
+            </a:r>
+          </a:p>
+          <a:p>
+            <a:pPr algn="l">
+              <a:spcAft>
+                <a:spcPts val="200"/>
+              </a:spcAft>
+            </a:pPr>
+            <a:r>
+              <a:rPr sz="1400">
                 <a:solidFill>
                   <a:srgbClr val="263642"/>
                 </a:solidFill>
                 <a:latin typeface="Microsoft YaHei"/>
               </a:rPr>
-              <a:t>教师基础反馈与三角色入口可用</a:t>
-            </a:r>
-          </a:p>
-        </p:txBody>
-      </p:sp>
-      <p:sp>
-        <p:nvSpPr>
-          <p:cNvPr id="20" name="TextBox 19"/>
-          <p:cNvSpPr txBox="1"/>
-          <p:nvPr/>
-        </p:nvSpPr>
-        <p:spPr>
-          <a:xfrm>
-            <a:off x="6236208" y="1600200"/>
-            <a:ext cx="1828800" cy="365760"/>
-          </a:xfrm>
-          <a:prstGeom prst="rect">
-            <a:avLst/>
-          </a:prstGeom>
-          <a:noFill/>
-        </p:spPr>
-        <p:txBody>
-          <a:bodyPr wrap="square" lIns="36576" rIns="36576" tIns="18288" bIns="18288" anchor="ctr">
-            <a:spAutoFit/>
-          </a:bodyPr>
-          <a:lstStyle/>
-          <a:p>
-            <a:pPr algn="l">
-              <a:spcAft>
-                <a:spcPts val="200"/>
-              </a:spcAft>
-            </a:pPr>
-            <a:r>
-              <a:rPr sz="2100" b="1">
-                <a:solidFill>
-                  <a:srgbClr val="D39A37"/>
-                </a:solidFill>
-                <a:latin typeface="Microsoft YaHei"/>
-              </a:rPr>
-              <a:t>下一步</a:t>
-            </a:r>
-          </a:p>
-        </p:txBody>
-      </p:sp>
-      <p:sp>
-        <p:nvSpPr>
-          <p:cNvPr id="21" name="Rounded Rectangle 20"/>
+              <a:t>结题非开发者试用 + 资源账单；不承诺公网</a:t>
+            </a:r>
+          </a:p>
+        </p:txBody>
+      </p:sp>
+      <p:sp>
+        <p:nvSpPr>
+          <p:cNvPr id="11" name="Rounded Rectangle 10"/>
           <p:cNvSpPr/>
           <p:nvPr/>
         </p:nvSpPr>
         <p:spPr>
           <a:xfrm>
-            <a:off x="6236208" y="2057400"/>
-            <a:ext cx="5074920" cy="530352"/>
-          </a:xfrm>
-          <a:prstGeom prst="roundRect">
-            <a:avLst/>
-          </a:prstGeom>
-          <a:solidFill>
-            <a:srgbClr val="FBF0D8"/>
-          </a:solidFill>
-          <a:ln w="13970">
-            <a:solidFill>
-              <a:srgbClr val="FBF0D8"/>
-            </a:solidFill>
-          </a:ln>
-        </p:spPr>
-        <p:style>
-          <a:lnRef idx="1">
-            <a:schemeClr val="accent1"/>
-          </a:lnRef>
-          <a:fillRef idx="3">
-            <a:schemeClr val="accent1"/>
-          </a:fillRef>
-          <a:effectRef idx="2">
-            <a:schemeClr val="accent1"/>
-          </a:effectRef>
-          <a:fontRef idx="minor">
-            <a:schemeClr val="lt1"/>
-          </a:fontRef>
-        </p:style>
-        <p:txBody>
-          <a:bodyPr rtlCol="0" anchor="ctr"/>
-          <a:lstStyle/>
-          <a:p>
-            <a:pPr algn="ctr"/>
-          </a:p>
-        </p:txBody>
-      </p:sp>
-      <p:sp>
-        <p:nvSpPr>
-          <p:cNvPr id="22" name="TextBox 21"/>
-          <p:cNvSpPr txBox="1"/>
-          <p:nvPr/>
-        </p:nvSpPr>
-        <p:spPr>
-          <a:xfrm>
-            <a:off x="6345936" y="2130552"/>
-            <a:ext cx="411480" cy="365760"/>
-          </a:xfrm>
-          <a:prstGeom prst="rect">
-            <a:avLst/>
-          </a:prstGeom>
-          <a:noFill/>
-        </p:spPr>
-        <p:txBody>
-          <a:bodyPr wrap="square" lIns="36576" rIns="36576" tIns="18288" bIns="18288" anchor="ctr">
-            <a:spAutoFit/>
-          </a:bodyPr>
-          <a:lstStyle/>
-          <a:p>
-            <a:pPr algn="ctr">
-              <a:spcAft>
-                <a:spcPts val="200"/>
-              </a:spcAft>
-            </a:pPr>
-            <a:r>
-              <a:rPr sz="1400" b="1">
-                <a:solidFill>
-                  <a:srgbClr val="D39A37"/>
-                </a:solidFill>
-                <a:latin typeface="Microsoft YaHei"/>
-              </a:rPr>
-              <a:t>01</a:t>
-            </a:r>
-          </a:p>
-        </p:txBody>
-      </p:sp>
-      <p:sp>
-        <p:nvSpPr>
-          <p:cNvPr id="23" name="TextBox 22"/>
-          <p:cNvSpPr txBox="1"/>
-          <p:nvPr/>
-        </p:nvSpPr>
-        <p:spPr>
-          <a:xfrm>
-            <a:off x="6839712" y="2130552"/>
-            <a:ext cx="4315968" cy="384048"/>
-          </a:xfrm>
-          <a:prstGeom prst="rect">
-            <a:avLst/>
-          </a:prstGeom>
-          <a:noFill/>
-        </p:spPr>
-        <p:txBody>
-          <a:bodyPr wrap="square" lIns="36576" rIns="36576" tIns="18288" bIns="18288" anchor="ctr">
-            <a:spAutoFit/>
-          </a:bodyPr>
-          <a:lstStyle/>
-          <a:p>
-            <a:pPr algn="l">
-              <a:spcAft>
-                <a:spcPts val="200"/>
-              </a:spcAft>
-            </a:pPr>
-            <a:r>
-              <a:rPr sz="1400" b="1">
-                <a:solidFill>
-                  <a:srgbClr val="263642"/>
-                </a:solidFill>
-                <a:latin typeface="Microsoft YaHei"/>
-              </a:rPr>
-              <a:t>答辩同学可按提纲重做 PPT 终稿</a:t>
-            </a:r>
-          </a:p>
-        </p:txBody>
-      </p:sp>
-      <p:sp>
-        <p:nvSpPr>
-          <p:cNvPr id="24" name="Rounded Rectangle 23"/>
-          <p:cNvSpPr/>
-          <p:nvPr/>
-        </p:nvSpPr>
-        <p:spPr>
-          <a:xfrm>
-            <a:off x="6236208" y="2715768"/>
-            <a:ext cx="5074920" cy="530352"/>
-          </a:xfrm>
-          <a:prstGeom prst="roundRect">
-            <a:avLst/>
-          </a:prstGeom>
-          <a:solidFill>
-            <a:srgbClr val="FBF0D8"/>
-          </a:solidFill>
-          <a:ln w="13970">
-            <a:solidFill>
-              <a:srgbClr val="FBF0D8"/>
-            </a:solidFill>
-          </a:ln>
-        </p:spPr>
-        <p:style>
-          <a:lnRef idx="1">
-            <a:schemeClr val="accent1"/>
-          </a:lnRef>
-          <a:fillRef idx="3">
-            <a:schemeClr val="accent1"/>
-          </a:fillRef>
-          <a:effectRef idx="2">
-            <a:schemeClr val="accent1"/>
-          </a:effectRef>
-          <a:fontRef idx="minor">
-            <a:schemeClr val="lt1"/>
-          </a:fontRef>
-        </p:style>
-        <p:txBody>
-          <a:bodyPr rtlCol="0" anchor="ctr"/>
-          <a:lstStyle/>
-          <a:p>
-            <a:pPr algn="ctr"/>
-          </a:p>
-        </p:txBody>
-      </p:sp>
-      <p:sp>
-        <p:nvSpPr>
-          <p:cNvPr id="25" name="TextBox 24"/>
-          <p:cNvSpPr txBox="1"/>
-          <p:nvPr/>
-        </p:nvSpPr>
-        <p:spPr>
-          <a:xfrm>
-            <a:off x="6345936" y="2788920"/>
-            <a:ext cx="411480" cy="365760"/>
-          </a:xfrm>
-          <a:prstGeom prst="rect">
-            <a:avLst/>
-          </a:prstGeom>
-          <a:noFill/>
-        </p:spPr>
-        <p:txBody>
-          <a:bodyPr wrap="square" lIns="36576" rIns="36576" tIns="18288" bIns="18288" anchor="ctr">
-            <a:spAutoFit/>
-          </a:bodyPr>
-          <a:lstStyle/>
-          <a:p>
-            <a:pPr algn="ctr">
-              <a:spcAft>
-                <a:spcPts val="200"/>
-              </a:spcAft>
-            </a:pPr>
-            <a:r>
-              <a:rPr sz="1400" b="1">
-                <a:solidFill>
-                  <a:srgbClr val="D39A37"/>
-                </a:solidFill>
-                <a:latin typeface="Microsoft YaHei"/>
-              </a:rPr>
-              <a:t>02</a:t>
-            </a:r>
-          </a:p>
-        </p:txBody>
-      </p:sp>
-      <p:sp>
-        <p:nvSpPr>
-          <p:cNvPr id="26" name="TextBox 25"/>
-          <p:cNvSpPr txBox="1"/>
-          <p:nvPr/>
-        </p:nvSpPr>
-        <p:spPr>
-          <a:xfrm>
-            <a:off x="6839712" y="2788920"/>
-            <a:ext cx="4315968" cy="384048"/>
-          </a:xfrm>
-          <a:prstGeom prst="rect">
-            <a:avLst/>
-          </a:prstGeom>
-          <a:noFill/>
-        </p:spPr>
-        <p:txBody>
-          <a:bodyPr wrap="square" lIns="36576" rIns="36576" tIns="18288" bIns="18288" anchor="ctr">
-            <a:spAutoFit/>
-          </a:bodyPr>
-          <a:lstStyle/>
-          <a:p>
-            <a:pPr algn="l">
-              <a:spcAft>
-                <a:spcPts val="200"/>
-              </a:spcAft>
-            </a:pPr>
-            <a:r>
-              <a:rPr sz="1400" b="1">
-                <a:solidFill>
-                  <a:srgbClr val="263642"/>
-                </a:solidFill>
-                <a:latin typeface="Microsoft YaHei"/>
-              </a:rPr>
-              <a:t>固定问句再彩排（模型已对齐 flash）</a:t>
-            </a:r>
-          </a:p>
-        </p:txBody>
-      </p:sp>
-      <p:sp>
-        <p:nvSpPr>
-          <p:cNvPr id="27" name="Rounded Rectangle 26"/>
-          <p:cNvSpPr/>
-          <p:nvPr/>
-        </p:nvSpPr>
-        <p:spPr>
-          <a:xfrm>
-            <a:off x="6236208" y="3374136"/>
-            <a:ext cx="5074920" cy="530352"/>
-          </a:xfrm>
-          <a:prstGeom prst="roundRect">
-            <a:avLst/>
-          </a:prstGeom>
-          <a:solidFill>
-            <a:srgbClr val="FBF0D8"/>
-          </a:solidFill>
-          <a:ln w="13970">
-            <a:solidFill>
-              <a:srgbClr val="FBF0D8"/>
-            </a:solidFill>
-          </a:ln>
-        </p:spPr>
-        <p:style>
-          <a:lnRef idx="1">
-            <a:schemeClr val="accent1"/>
-          </a:lnRef>
-          <a:fillRef idx="3">
-            <a:schemeClr val="accent1"/>
-          </a:fillRef>
-          <a:effectRef idx="2">
-            <a:schemeClr val="accent1"/>
-          </a:effectRef>
-          <a:fontRef idx="minor">
-            <a:schemeClr val="lt1"/>
-          </a:fontRef>
-        </p:style>
-        <p:txBody>
-          <a:bodyPr rtlCol="0" anchor="ctr"/>
-          <a:lstStyle/>
-          <a:p>
-            <a:pPr algn="ctr"/>
-          </a:p>
-        </p:txBody>
-      </p:sp>
-      <p:sp>
-        <p:nvSpPr>
-          <p:cNvPr id="28" name="TextBox 27"/>
-          <p:cNvSpPr txBox="1"/>
-          <p:nvPr/>
-        </p:nvSpPr>
-        <p:spPr>
-          <a:xfrm>
-            <a:off x="6345936" y="3447288"/>
-            <a:ext cx="411480" cy="365760"/>
-          </a:xfrm>
-          <a:prstGeom prst="rect">
-            <a:avLst/>
-          </a:prstGeom>
-          <a:noFill/>
-        </p:spPr>
-        <p:txBody>
-          <a:bodyPr wrap="square" lIns="36576" rIns="36576" tIns="18288" bIns="18288" anchor="ctr">
-            <a:spAutoFit/>
-          </a:bodyPr>
-          <a:lstStyle/>
-          <a:p>
-            <a:pPr algn="ctr">
-              <a:spcAft>
-                <a:spcPts val="200"/>
-              </a:spcAft>
-            </a:pPr>
-            <a:r>
-              <a:rPr sz="1400" b="1">
-                <a:solidFill>
-                  <a:srgbClr val="D39A37"/>
-                </a:solidFill>
-                <a:latin typeface="Microsoft YaHei"/>
-              </a:rPr>
-              <a:t>03</a:t>
-            </a:r>
-          </a:p>
-        </p:txBody>
-      </p:sp>
-      <p:sp>
-        <p:nvSpPr>
-          <p:cNvPr id="29" name="TextBox 28"/>
-          <p:cNvSpPr txBox="1"/>
-          <p:nvPr/>
-        </p:nvSpPr>
-        <p:spPr>
-          <a:xfrm>
-            <a:off x="6839712" y="3447288"/>
-            <a:ext cx="4315968" cy="384048"/>
-          </a:xfrm>
-          <a:prstGeom prst="rect">
-            <a:avLst/>
-          </a:prstGeom>
-          <a:noFill/>
-        </p:spPr>
-        <p:txBody>
-          <a:bodyPr wrap="square" lIns="36576" rIns="36576" tIns="18288" bIns="18288" anchor="ctr">
-            <a:spAutoFit/>
-          </a:bodyPr>
-          <a:lstStyle/>
-          <a:p>
-            <a:pPr algn="l">
-              <a:spcAft>
-                <a:spcPts val="200"/>
-              </a:spcAft>
-            </a:pPr>
-            <a:r>
-              <a:rPr sz="1400" b="1">
-                <a:solidFill>
-                  <a:srgbClr val="263642"/>
-                </a:solidFill>
-                <a:latin typeface="Microsoft YaHei"/>
-              </a:rPr>
-              <a:t>小规模人工事实与引用复核</a:t>
-            </a:r>
-          </a:p>
-        </p:txBody>
-      </p:sp>
-      <p:sp>
-        <p:nvSpPr>
-          <p:cNvPr id="30" name="Rounded Rectangle 29"/>
-          <p:cNvSpPr/>
-          <p:nvPr/>
-        </p:nvSpPr>
-        <p:spPr>
-          <a:xfrm>
-            <a:off x="6236208" y="4032504"/>
-            <a:ext cx="5074920" cy="530352"/>
-          </a:xfrm>
-          <a:prstGeom prst="roundRect">
-            <a:avLst/>
-          </a:prstGeom>
-          <a:solidFill>
-            <a:srgbClr val="FBF0D8"/>
-          </a:solidFill>
-          <a:ln w="13970">
-            <a:solidFill>
-              <a:srgbClr val="FBF0D8"/>
-            </a:solidFill>
-          </a:ln>
-        </p:spPr>
-        <p:style>
-          <a:lnRef idx="1">
-            <a:schemeClr val="accent1"/>
-          </a:lnRef>
-          <a:fillRef idx="3">
-            <a:schemeClr val="accent1"/>
-          </a:fillRef>
-          <a:effectRef idx="2">
-            <a:schemeClr val="accent1"/>
-          </a:effectRef>
-          <a:fontRef idx="minor">
-            <a:schemeClr val="lt1"/>
-          </a:fontRef>
-        </p:style>
-        <p:txBody>
-          <a:bodyPr rtlCol="0" anchor="ctr"/>
-          <a:lstStyle/>
-          <a:p>
-            <a:pPr algn="ctr"/>
-          </a:p>
-        </p:txBody>
-      </p:sp>
-      <p:sp>
-        <p:nvSpPr>
-          <p:cNvPr id="31" name="TextBox 30"/>
-          <p:cNvSpPr txBox="1"/>
-          <p:nvPr/>
-        </p:nvSpPr>
-        <p:spPr>
-          <a:xfrm>
-            <a:off x="6345936" y="4105656"/>
-            <a:ext cx="411480" cy="365760"/>
-          </a:xfrm>
-          <a:prstGeom prst="rect">
-            <a:avLst/>
-          </a:prstGeom>
-          <a:noFill/>
-        </p:spPr>
-        <p:txBody>
-          <a:bodyPr wrap="square" lIns="36576" rIns="36576" tIns="18288" bIns="18288" anchor="ctr">
-            <a:spAutoFit/>
-          </a:bodyPr>
-          <a:lstStyle/>
-          <a:p>
-            <a:pPr algn="ctr">
-              <a:spcAft>
-                <a:spcPts val="200"/>
-              </a:spcAft>
-            </a:pPr>
-            <a:r>
-              <a:rPr sz="1400" b="1">
-                <a:solidFill>
-                  <a:srgbClr val="D39A37"/>
-                </a:solidFill>
-                <a:latin typeface="Microsoft YaHei"/>
-              </a:rPr>
-              <a:t>04</a:t>
-            </a:r>
-          </a:p>
-        </p:txBody>
-      </p:sp>
-      <p:sp>
-        <p:nvSpPr>
-          <p:cNvPr id="32" name="TextBox 31"/>
-          <p:cNvSpPr txBox="1"/>
-          <p:nvPr/>
-        </p:nvSpPr>
-        <p:spPr>
-          <a:xfrm>
-            <a:off x="6839712" y="4105656"/>
-            <a:ext cx="4315968" cy="384048"/>
-          </a:xfrm>
-          <a:prstGeom prst="rect">
-            <a:avLst/>
-          </a:prstGeom>
-          <a:noFill/>
-        </p:spPr>
-        <p:txBody>
-          <a:bodyPr wrap="square" lIns="36576" rIns="36576" tIns="18288" bIns="18288" anchor="ctr">
-            <a:spAutoFit/>
-          </a:bodyPr>
-          <a:lstStyle/>
-          <a:p>
-            <a:pPr algn="l">
-              <a:spcAft>
-                <a:spcPts val="200"/>
-              </a:spcAft>
-            </a:pPr>
-            <a:r>
-              <a:rPr sz="1400" b="1">
-                <a:solidFill>
-                  <a:srgbClr val="263642"/>
-                </a:solidFill>
-                <a:latin typeface="Microsoft YaHei"/>
-              </a:rPr>
-              <a:t>成本/资源专项与结题试用</a:t>
-            </a:r>
-          </a:p>
-        </p:txBody>
-      </p:sp>
-      <p:sp>
-        <p:nvSpPr>
-          <p:cNvPr id="33" name="Rounded Rectangle 32"/>
-          <p:cNvSpPr/>
-          <p:nvPr/>
-        </p:nvSpPr>
-        <p:spPr>
-          <a:xfrm>
-            <a:off x="749808" y="5074920"/>
-            <a:ext cx="10561320" cy="777240"/>
+            <a:off x="502920" y="4892040"/>
+            <a:ext cx="11155680" cy="960120"/>
           </a:xfrm>
           <a:prstGeom prst="roundRect">
             <a:avLst/>
@@ -5247,14 +4481,14 @@
       </p:sp>
       <p:sp>
         <p:nvSpPr>
-          <p:cNvPr id="34" name="TextBox 33"/>
+          <p:cNvPr id="12" name="TextBox 11"/>
           <p:cNvSpPr txBox="1"/>
           <p:nvPr/>
         </p:nvSpPr>
         <p:spPr>
           <a:xfrm>
-            <a:off x="960120" y="5257800"/>
-            <a:ext cx="10149840" cy="411480"/>
+            <a:off x="731520" y="5074920"/>
+            <a:ext cx="10698480" cy="594360"/>
           </a:xfrm>
           <a:prstGeom prst="rect">
             <a:avLst/>
@@ -5273,13 +4507,13 @@
               </a:spcAft>
             </a:pPr>
             <a:r>
-              <a:rPr sz="1700" b="1">
+              <a:rPr sz="1600" b="1">
                 <a:solidFill>
                   <a:srgbClr val="FFFFFF"/>
                 </a:solidFill>
                 <a:latin typeface="Microsoft YaHei"/>
               </a:rPr>
-              <a:t>结论：本机可演示的有依据课程问答原型；参考稿供队友改写，终稿可由答辩同学重做。</a:t>
+              <a:t>结论：双叙事亮点可讲清——课界+证据闭环，与页级检索/生成技术；本机可演示。开题「重点争取」项诚实后置。</a:t>
             </a:r>
           </a:p>
         </p:txBody>
@@ -6920,7 +6154,7 @@
                 </a:solidFill>
                 <a:latin typeface="Microsoft YaHei"/>
               </a:rPr>
-              <a:t>三项技术特色</a:t>
+              <a:t>技术亮点 · 双叙事</a:t>
             </a:r>
           </a:p>
         </p:txBody>
@@ -6959,7 +6193,7 @@
                 </a:solidFill>
                 <a:latin typeface="Microsoft YaHei"/>
               </a:rPr>
-              <a:t>开题方案研究重点：资料可追溯、检索可对照、回答可核对（开源复用，不自造平台）</a:t>
+              <a:t>教学场景闭环 + 检索/生成技术；中期只讲能演示、有证据的能力</a:t>
             </a:r>
           </a:p>
         </p:txBody>
@@ -7095,8 +6329,8 @@
         </p:nvSpPr>
         <p:spPr>
           <a:xfrm>
-            <a:off x="640080" y="1645920"/>
-            <a:ext cx="3520440" cy="3840480"/>
+            <a:off x="502920" y="1600200"/>
+            <a:ext cx="5532120" cy="3977639"/>
           </a:xfrm>
           <a:prstGeom prst="roundRect">
             <a:avLst/>
@@ -7134,13 +6368,13 @@
               </a:spcAft>
             </a:pPr>
             <a:r>
-              <a:rPr sz="1800" b="1">
+              <a:rPr sz="1900" b="1">
                 <a:solidFill>
                   <a:srgbClr val="247D78"/>
                 </a:solidFill>
                 <a:latin typeface="Microsoft YaHei"/>
               </a:rPr>
-              <a:t>① 可追溯的资料组织</a:t>
+              <a:t>A. 教学场景闭环</a:t>
             </a:r>
           </a:p>
           <a:p>
@@ -7156,7 +6390,7 @@
                 </a:solidFill>
                 <a:latin typeface="Microsoft YaHei"/>
               </a:rPr>
-              <a:t>PyMuPDF 原生文字提取</a:t>
+              <a:t>• 课界权限贯穿检索—生成—打开原文件</a:t>
             </a:r>
           </a:p>
           <a:p>
@@ -7172,7 +6406,7 @@
                 </a:solidFill>
                 <a:latin typeface="Microsoft YaHei"/>
               </a:rPr>
-              <a:t>保留页码与逐页质量记录</a:t>
+              <a:t>• 证据不足可拒答，不编造课外步骤</a:t>
             </a:r>
           </a:p>
           <a:p>
@@ -7188,7 +6422,7 @@
                 </a:solidFill>
                 <a:latin typeface="Microsoft YaHei"/>
               </a:rPr>
-              <a:t>空页 / 稀疏页 / 异常可登记</a:t>
+              <a:t>• 引用带回原 PDF 页（#page=）</a:t>
             </a:r>
           </a:p>
           <a:p>
@@ -7204,7 +6438,7 @@
                 </a:solidFill>
                 <a:latin typeface="Microsoft YaHei"/>
               </a:rPr>
-              <a:t>资料哈希、切分与索引版本可解释</a:t>
+              <a:t>• 三角色分工清晰，不是单一聊天窗</a:t>
             </a:r>
           </a:p>
           <a:p>
@@ -7220,7 +6454,7 @@
                 </a:solidFill>
                 <a:latin typeface="Microsoft YaHei"/>
               </a:rPr>
-              <a:t>Markdown / Chunk 是派生视图</a:t>
+              <a:t>• 教师问答反馈：高频问句与依据不足线索</a:t>
             </a:r>
           </a:p>
         </p:txBody>
@@ -7233,146 +6467,8 @@
         </p:nvSpPr>
         <p:spPr>
           <a:xfrm>
-            <a:off x="4343400" y="1645920"/>
-            <a:ext cx="3520440" cy="3840480"/>
-          </a:xfrm>
-          <a:prstGeom prst="roundRect">
-            <a:avLst/>
-          </a:prstGeom>
-          <a:solidFill>
-            <a:srgbClr val="FFFFFF"/>
-          </a:solidFill>
-          <a:ln w="13970">
-            <a:solidFill>
-              <a:srgbClr val="D6E0E5"/>
-            </a:solidFill>
-          </a:ln>
-        </p:spPr>
-        <p:style>
-          <a:lnRef idx="1">
-            <a:schemeClr val="accent1"/>
-          </a:lnRef>
-          <a:fillRef idx="3">
-            <a:schemeClr val="accent1"/>
-          </a:fillRef>
-          <a:effectRef idx="2">
-            <a:schemeClr val="accent1"/>
-          </a:effectRef>
-          <a:fontRef idx="minor">
-            <a:schemeClr val="lt1"/>
-          </a:fontRef>
-        </p:style>
-        <p:txBody>
-          <a:bodyPr rtlCol="0" anchor="t" wrap="square" lIns="146304" rIns="146304" tIns="91440" bIns="73152"/>
-          <a:lstStyle/>
-          <a:p>
-            <a:pPr algn="l">
-              <a:spcAft>
-                <a:spcPts val="600"/>
-              </a:spcAft>
-            </a:pPr>
-            <a:r>
-              <a:rPr sz="1800" b="1">
-                <a:solidFill>
-                  <a:srgbClr val="D39A37"/>
-                </a:solidFill>
-                <a:latin typeface="Microsoft YaHei"/>
-              </a:rPr>
-              <a:t>② 课程内检索（可对照）</a:t>
-            </a:r>
-          </a:p>
-          <a:p>
-            <a:pPr algn="l">
-              <a:spcAft>
-                <a:spcPts val="200"/>
-              </a:spcAft>
-            </a:pPr>
-            <a:r>
-              <a:rPr sz="1500">
-                <a:solidFill>
-                  <a:srgbClr val="263642"/>
-                </a:solidFill>
-                <a:latin typeface="Microsoft YaHei"/>
-              </a:rPr>
-              <a:t>中期演示默认：Dense</a:t>
-            </a:r>
-          </a:p>
-          <a:p>
-            <a:pPr algn="l">
-              <a:spcAft>
-                <a:spcPts val="200"/>
-              </a:spcAft>
-            </a:pPr>
-            <a:r>
-              <a:rPr sz="1500">
-                <a:solidFill>
-                  <a:srgbClr val="263642"/>
-                </a:solidFill>
-                <a:latin typeface="Microsoft YaHei"/>
-              </a:rPr>
-              <a:t>Hybrid / BM25 / rerank</a:t>
-            </a:r>
-          </a:p>
-          <a:p>
-            <a:pPr algn="l">
-              <a:spcAft>
-                <a:spcPts val="200"/>
-              </a:spcAft>
-            </a:pPr>
-            <a:r>
-              <a:rPr sz="1500">
-                <a:solidFill>
-                  <a:srgbClr val="263642"/>
-                </a:solidFill>
-                <a:latin typeface="Microsoft YaHei"/>
-              </a:rPr>
-              <a:t>已实现、可开关</a:t>
-            </a:r>
-          </a:p>
-          <a:p>
-            <a:pPr algn="l">
-              <a:spcAft>
-                <a:spcPts val="200"/>
-              </a:spcAft>
-            </a:pPr>
-            <a:r>
-              <a:rPr sz="1500">
-                <a:solidFill>
-                  <a:srgbClr val="263642"/>
-                </a:solidFill>
-                <a:latin typeface="Microsoft YaHei"/>
-              </a:rPr>
-              <a:t>不作中期主结论</a:t>
-            </a:r>
-          </a:p>
-          <a:p>
-            <a:pPr algn="l">
-              <a:spcAft>
-                <a:spcPts val="200"/>
-              </a:spcAft>
-            </a:pPr>
-            <a:r>
-              <a:rPr sz="1500">
-                <a:solidFill>
-                  <a:srgbClr val="263642"/>
-                </a:solidFill>
-                <a:latin typeface="Microsoft YaHei"/>
-              </a:rPr>
-              <a:t>权限贯穿候选与缓存</a:t>
-            </a:r>
-          </a:p>
-        </p:txBody>
-      </p:sp>
-      <p:sp>
-        <p:nvSpPr>
-          <p:cNvPr id="9" name="Rounded Rectangle 8"/>
-          <p:cNvSpPr/>
-          <p:nvPr/>
-        </p:nvSpPr>
-        <p:spPr>
-          <a:xfrm>
-            <a:off x="8046720" y="1645920"/>
-            <a:ext cx="3520440" cy="3840480"/>
+            <a:off x="6263640" y="1600200"/>
+            <a:ext cx="5349240" cy="3977639"/>
           </a:xfrm>
           <a:prstGeom prst="roundRect">
             <a:avLst/>
@@ -7410,13 +6506,13 @@
               </a:spcAft>
             </a:pPr>
             <a:r>
-              <a:rPr sz="1800" b="1">
+              <a:rPr sz="1900" b="1">
                 <a:solidFill>
                   <a:srgbClr val="D39A37"/>
                 </a:solidFill>
                 <a:latin typeface="Microsoft YaHei"/>
               </a:rPr>
-              <a:t>③ 可核对的证据回答</a:t>
+              <a:t>B. 检索 / 生成技术</a:t>
             </a:r>
           </a:p>
           <a:p>
@@ -7432,7 +6528,7 @@
                 </a:solidFill>
                 <a:latin typeface="Microsoft YaHei"/>
               </a:rPr>
-              <a:t>只引用实际送入上下文的来源</a:t>
+              <a:t>• 页级解析 + 质量门禁（PyMuPDF）</a:t>
             </a:r>
           </a:p>
           <a:p>
@@ -7448,7 +6544,7 @@
                 </a:solidFill>
                 <a:latin typeface="Microsoft YaHei"/>
               </a:rPr>
-              <a:t>区分有据回答 / 依据不足 / 失败</a:t>
+              <a:t>• 向量检索 BGE-M3 + 证据约束生成</a:t>
             </a:r>
           </a:p>
           <a:p>
@@ -7464,7 +6560,7 @@
                 </a:solidFill>
                 <a:latin typeface="Microsoft YaHei"/>
               </a:rPr>
-              <a:t>学生可打开原 PDF #page=</a:t>
+              <a:t>• DeepSeek（deepseek-flash）</a:t>
             </a:r>
           </a:p>
           <a:p>
@@ -7480,7 +6576,39 @@
                 </a:solidFill>
                 <a:latin typeface="Microsoft YaHei"/>
               </a:rPr>
-              <a:t>合法引用 ≠ 事实主张被支持</a:t>
+              <a:t>• dense / hybrid / rerank 已实现可开关</a:t>
+            </a:r>
+          </a:p>
+          <a:p>
+            <a:pPr algn="l">
+              <a:spcAft>
+                <a:spcPts val="200"/>
+              </a:spcAft>
+            </a:pPr>
+            <a:r>
+              <a:rPr sz="1500">
+                <a:solidFill>
+                  <a:srgbClr val="263642"/>
+                </a:solidFill>
+                <a:latin typeface="Microsoft YaHei"/>
+              </a:rPr>
+              <a:t>• 中期主演示：dense，rerank 关</a:t>
+            </a:r>
+          </a:p>
+          <a:p>
+            <a:pPr algn="l">
+              <a:spcAft>
+                <a:spcPts val="200"/>
+              </a:spcAft>
+            </a:pPr>
+            <a:r>
+              <a:rPr sz="1500">
+                <a:solidFill>
+                  <a:srgbClr val="263642"/>
+                </a:solidFill>
+                <a:latin typeface="Microsoft YaHei"/>
+              </a:rPr>
+              <a:t>• Hybrid 对照实验放后期，不作主结论</a:t>
             </a:r>
           </a:p>
         </p:txBody>
@@ -11298,7 +10426,7 @@
                 </a:solidFill>
                 <a:latin typeface="Microsoft YaHei"/>
               </a:rPr>
-              <a:t>诚实限制</a:t>
+              <a:t>现有不足（三条）</a:t>
             </a:r>
           </a:p>
         </p:txBody>
@@ -11337,7 +10465,7 @@
                 </a:solidFill>
                 <a:latin typeface="Microsoft YaHei"/>
               </a:rPr>
-              <a:t>工程闭环与通用 RAG 质量是两回事；只陈述有证据的能力</a:t>
+              <a:t>把边界讲清楚，比夸大进展更有说服力</a:t>
             </a:r>
           </a:p>
         </p:txBody>
@@ -11473,8 +10601,8 @@
         </p:nvSpPr>
         <p:spPr>
           <a:xfrm>
-            <a:off x="640080" y="1645920"/>
-            <a:ext cx="5394960" cy="3794760"/>
+            <a:off x="502920" y="1645920"/>
+            <a:ext cx="3611880" cy="3886200"/>
           </a:xfrm>
           <a:prstGeom prst="roundRect">
             <a:avLst/>
@@ -11512,93 +10640,77 @@
               </a:spcAft>
             </a:pPr>
             <a:r>
-              <a:rPr sz="1900" b="1">
+              <a:rPr sz="1800" b="1">
                 <a:solidFill>
                   <a:srgbClr val="B84242"/>
                 </a:solidFill>
                 <a:latin typeface="Microsoft YaHei"/>
               </a:rPr>
-              <a:t>评价口径</a:t>
-            </a:r>
-          </a:p>
-          <a:p>
-            <a:pPr algn="l">
-              <a:spcAft>
-                <a:spcPts val="200"/>
-              </a:spcAft>
-            </a:pPr>
-            <a:r>
-              <a:rPr sz="1600">
+              <a:t>① 评价未人工复核</a:t>
+            </a:r>
+          </a:p>
+          <a:p>
+            <a:pPr algn="l">
+              <a:spcAft>
+                <a:spcPts val="200"/>
+              </a:spcAft>
+            </a:pPr>
+            <a:r>
+              <a:rPr sz="1500">
                 <a:solidFill>
                   <a:srgbClr val="263642"/>
                 </a:solidFill>
                 <a:latin typeface="Microsoft YaHei"/>
               </a:rPr>
-              <a:t>• 事实正确 ≠ 引用支持</a:t>
-            </a:r>
-          </a:p>
-          <a:p>
-            <a:pPr algn="l">
-              <a:spcAft>
-                <a:spcPts val="200"/>
-              </a:spcAft>
-            </a:pPr>
-            <a:r>
-              <a:rPr sz="1600">
+              <a:t>仅有弱规则命中与拒答</a:t>
+            </a:r>
+          </a:p>
+          <a:p>
+            <a:pPr algn="l">
+              <a:spcAft>
+                <a:spcPts val="200"/>
+              </a:spcAft>
+            </a:pPr>
+            <a:r>
+              <a:rPr sz="1500">
                 <a:solidFill>
                   <a:srgbClr val="263642"/>
                 </a:solidFill>
                 <a:latin typeface="Microsoft YaHei"/>
               </a:rPr>
-              <a:t>• 12/12 与 4/4 是弱自动化规则</a:t>
-            </a:r>
-          </a:p>
-          <a:p>
-            <a:pPr algn="l">
-              <a:spcAft>
-                <a:spcPts val="200"/>
-              </a:spcAft>
-            </a:pPr>
-            <a:r>
-              <a:rPr sz="1600">
+              <a:t>事实正确 ≠ 引用支持</a:t>
+            </a:r>
+          </a:p>
+          <a:p>
+            <a:pPr algn="l">
+              <a:spcAft>
+                <a:spcPts val="200"/>
+              </a:spcAft>
+            </a:pPr>
+            <a:r>
+              <a:rPr sz="1500">
                 <a:solidFill>
                   <a:srgbClr val="263642"/>
                 </a:solidFill>
                 <a:latin typeface="Microsoft YaHei"/>
               </a:rPr>
-              <a:t>• AI 预标题集未经独立人工复核</a:t>
-            </a:r>
-          </a:p>
-          <a:p>
-            <a:pPr algn="l">
-              <a:spcAft>
-                <a:spcPts val="200"/>
-              </a:spcAft>
-            </a:pPr>
-            <a:r>
-              <a:rPr sz="1600">
+              <a:t>尚无独立人工事实正确率</a:t>
+            </a:r>
+          </a:p>
+          <a:p>
+            <a:pPr algn="l">
+              <a:spcAft>
+                <a:spcPts val="200"/>
+              </a:spcAft>
+            </a:pPr>
+            <a:r>
+              <a:rPr sz="1500">
                 <a:solidFill>
                   <a:srgbClr val="263642"/>
                 </a:solidFill>
                 <a:latin typeface="Microsoft YaHei"/>
               </a:rPr>
-              <a:t>• 余弦阈值 0.45 未校准</a:t>
-            </a:r>
-          </a:p>
-          <a:p>
-            <a:pPr algn="l">
-              <a:spcAft>
-                <a:spcPts val="200"/>
-              </a:spcAft>
-            </a:pPr>
-            <a:r>
-              <a:rPr sz="1600">
-                <a:solidFill>
-                  <a:srgbClr val="263642"/>
-                </a:solidFill>
-                <a:latin typeface="Microsoft YaHei"/>
-              </a:rPr>
-              <a:t>• Hybrid/rerank 不作中期主结论</a:t>
+              <a:t>题集为 AI 预标</a:t>
             </a:r>
           </a:p>
         </p:txBody>
@@ -11611,8 +10723,8 @@
         </p:nvSpPr>
         <p:spPr>
           <a:xfrm>
-            <a:off x="6263640" y="1645920"/>
-            <a:ext cx="5257800" cy="3794760"/>
+            <a:off x="4297680" y="1645920"/>
+            <a:ext cx="3611880" cy="3886200"/>
           </a:xfrm>
           <a:prstGeom prst="roundRect">
             <a:avLst/>
@@ -11650,93 +10762,199 @@
               </a:spcAft>
             </a:pPr>
             <a:r>
-              <a:rPr sz="1900" b="1">
+              <a:rPr sz="1800" b="1">
                 <a:solidFill>
                   <a:srgbClr val="D39A37"/>
                 </a:solidFill>
                 <a:latin typeface="Microsoft YaHei"/>
               </a:rPr>
-              <a:t>能力与交付边界</a:t>
-            </a:r>
-          </a:p>
-          <a:p>
-            <a:pPr algn="l">
-              <a:spcAft>
-                <a:spcPts val="200"/>
-              </a:spcAft>
-            </a:pPr>
-            <a:r>
-              <a:rPr sz="1600">
+              <a:t>② 复杂资料未覆盖</a:t>
+            </a:r>
+          </a:p>
+          <a:p>
+            <a:pPr algn="l">
+              <a:spcAft>
+                <a:spcPts val="200"/>
+              </a:spcAft>
+            </a:pPr>
+            <a:r>
+              <a:rPr sz="1500">
                 <a:solidFill>
                   <a:srgbClr val="263642"/>
                 </a:solidFill>
                 <a:latin typeface="Microsoft YaHei"/>
               </a:rPr>
-              <a:t>• 非 OCR / 公式 / 图表理解主线</a:t>
-            </a:r>
-          </a:p>
-          <a:p>
-            <a:pPr algn="l">
-              <a:spcAft>
-                <a:spcPts val="200"/>
-              </a:spcAft>
-            </a:pPr>
-            <a:r>
-              <a:rPr sz="1600">
+              <a:t>非 OCR / 扫描件主线</a:t>
+            </a:r>
+          </a:p>
+          <a:p>
+            <a:pPr algn="l">
+              <a:spcAft>
+                <a:spcPts val="200"/>
+              </a:spcAft>
+            </a:pPr>
+            <a:r>
+              <a:rPr sz="1500">
                 <a:solidFill>
                   <a:srgbClr val="263642"/>
                 </a:solidFill>
                 <a:latin typeface="Microsoft YaHei"/>
               </a:rPr>
-              <a:t>• 非校园网生产部署</a:t>
-            </a:r>
-          </a:p>
-          <a:p>
-            <a:pPr algn="l">
-              <a:spcAft>
-                <a:spcPts val="200"/>
-              </a:spcAft>
-            </a:pPr>
-            <a:r>
-              <a:rPr sz="1600">
+              <a:t>公式与图表理解有限</a:t>
+            </a:r>
+          </a:p>
+          <a:p>
+            <a:pPr algn="l">
+              <a:spcAft>
+                <a:spcPts val="200"/>
+              </a:spcAft>
+            </a:pPr>
+            <a:r>
+              <a:rPr sz="1500">
                 <a:solidFill>
                   <a:srgbClr val="263642"/>
                 </a:solidFill>
                 <a:latin typeface="Microsoft YaHei"/>
               </a:rPr>
-              <a:t>• 供应商账单、依赖锁定待验</a:t>
-            </a:r>
-          </a:p>
-          <a:p>
-            <a:pPr algn="l">
-              <a:spcAft>
-                <a:spcPts val="200"/>
-              </a:spcAft>
-            </a:pPr>
-            <a:r>
-              <a:rPr sz="1600">
+              <a:t>纯图页覆盖不全</a:t>
+            </a:r>
+          </a:p>
+          <a:p>
+            <a:pPr algn="l">
+              <a:spcAft>
+                <a:spcPts val="200"/>
+              </a:spcAft>
+            </a:pPr>
+            <a:r>
+              <a:rPr sz="1500">
                 <a:solidFill>
                   <a:srgbClr val="263642"/>
                 </a:solidFill>
                 <a:latin typeface="Microsoft YaHei"/>
               </a:rPr>
-              <a:t>• Demo Reset / 成本专项待验</a:t>
-            </a:r>
-          </a:p>
-          <a:p>
-            <a:pPr algn="l">
-              <a:spcAft>
-                <a:spcPts val="200"/>
-              </a:spcAft>
-            </a:pPr>
-            <a:r>
-              <a:rPr sz="1600">
+              <a:t>文字层 PDF 是中期范围</a:t>
+            </a:r>
+          </a:p>
+        </p:txBody>
+      </p:sp>
+      <p:sp>
+        <p:nvSpPr>
+          <p:cNvPr id="9" name="Rounded Rectangle 8"/>
+          <p:cNvSpPr/>
+          <p:nvPr/>
+        </p:nvSpPr>
+        <p:spPr>
+          <a:xfrm>
+            <a:off x="8092440" y="1645920"/>
+            <a:ext cx="3520440" cy="3886200"/>
+          </a:xfrm>
+          <a:prstGeom prst="roundRect">
+            <a:avLst/>
+          </a:prstGeom>
+          <a:solidFill>
+            <a:srgbClr val="FFFFFF"/>
+          </a:solidFill>
+          <a:ln w="13970">
+            <a:solidFill>
+              <a:srgbClr val="D6E0E5"/>
+            </a:solidFill>
+          </a:ln>
+        </p:spPr>
+        <p:style>
+          <a:lnRef idx="1">
+            <a:schemeClr val="accent1"/>
+          </a:lnRef>
+          <a:fillRef idx="3">
+            <a:schemeClr val="accent1"/>
+          </a:fillRef>
+          <a:effectRef idx="2">
+            <a:schemeClr val="accent1"/>
+          </a:effectRef>
+          <a:fontRef idx="minor">
+            <a:schemeClr val="lt1"/>
+          </a:fontRef>
+        </p:style>
+        <p:txBody>
+          <a:bodyPr rtlCol="0" anchor="t" wrap="square" lIns="146304" rIns="146304" tIns="91440" bIns="73152"/>
+          <a:lstStyle/>
+          <a:p>
+            <a:pPr algn="l">
+              <a:spcAft>
+                <a:spcPts val="600"/>
+              </a:spcAft>
+            </a:pPr>
+            <a:r>
+              <a:rPr sz="1800" b="1">
+                <a:solidFill>
+                  <a:srgbClr val="163247"/>
+                </a:solidFill>
+                <a:latin typeface="Microsoft YaHei"/>
+              </a:rPr>
+              <a:t>③ 产品化待验</a:t>
+            </a:r>
+          </a:p>
+          <a:p>
+            <a:pPr algn="l">
+              <a:spcAft>
+                <a:spcPts val="200"/>
+              </a:spcAft>
+            </a:pPr>
+            <a:r>
+              <a:rPr sz="1500">
                 <a:solidFill>
                   <a:srgbClr val="263642"/>
                 </a:solidFill>
                 <a:latin typeface="Microsoft YaHei"/>
               </a:rPr>
-              <a:t>• 非开发者独立试用尚未完成</a:t>
+              <a:t>阈值与同义分组未校准</a:t>
+            </a:r>
+          </a:p>
+          <a:p>
+            <a:pPr algn="l">
+              <a:spcAft>
+                <a:spcPts val="200"/>
+              </a:spcAft>
+            </a:pPr>
+            <a:r>
+              <a:rPr sz="1500">
+                <a:solidFill>
+                  <a:srgbClr val="263642"/>
+                </a:solidFill>
+                <a:latin typeface="Microsoft YaHei"/>
+              </a:rPr>
+              <a:t>供应商账单 / 成本待验</a:t>
+            </a:r>
+          </a:p>
+          <a:p>
+            <a:pPr algn="l">
+              <a:spcAft>
+                <a:spcPts val="200"/>
+              </a:spcAft>
+            </a:pPr>
+            <a:r>
+              <a:rPr sz="1500">
+                <a:solidFill>
+                  <a:srgbClr val="263642"/>
+                </a:solidFill>
+                <a:latin typeface="Microsoft YaHei"/>
+              </a:rPr>
+              <a:t>单机演示，非校园网并发</a:t>
+            </a:r>
+          </a:p>
+          <a:p>
+            <a:pPr algn="l">
+              <a:spcAft>
+                <a:spcPts val="200"/>
+              </a:spcAft>
+            </a:pPr>
+            <a:r>
+              <a:rPr sz="1500">
+                <a:solidFill>
+                  <a:srgbClr val="263642"/>
+                </a:solidFill>
+                <a:latin typeface="Microsoft YaHei"/>
+              </a:rPr>
+              <a:t>开题争取项尚未全部兑现</a:t>
             </a:r>
           </a:p>
         </p:txBody>

</xml_diff>